<commit_message>
auto(portfolio): SPC 포트폴리오 PPT 2026-06-16
</commit_message>
<xml_diff>
--- a/reports/portfolio/2026-06-16.pptx
+++ b/reports/portfolio/2026-06-16.pptx
@@ -3191,7 +3191,7 @@
                   <a:srgbClr val="555555"/>
                 </a:solidFill>
               </a:rPr>
-              <a:t>분석 기간: 2026-02-28 ~ 2026-06-01</a:t>
+              <a:t>분석 기간: 2026-02-28 ~ 2026-06-16</a:t>
             </a:r>
           </a:p>
           <a:p>
@@ -3202,7 +3202,7 @@
                   <a:srgbClr val="555555"/>
                 </a:solidFill>
               </a:rPr>
-              <a:t>데이터: 총 11,085건 · 측정소 5곳 · 1시간 해상도</a:t>
+              <a:t>데이터: 총 12,855건 · 측정소 5곳 · 1시간 해상도</a:t>
             </a:r>
           </a:p>
           <a:p>
@@ -3213,7 +3213,7 @@
                   <a:srgbClr val="555555"/>
                 </a:solidFill>
               </a:rPr>
-              <a:t>생성일: 2026-06-16 12:50 KST</a:t>
+              <a:t>생성일: 2026-06-16 12:53 KST</a:t>
             </a:r>
           </a:p>
         </p:txBody>
@@ -3963,7 +3963,7 @@
                   <a:srgbClr val="555555"/>
                 </a:solidFill>
               </a:rPr>
-              <a:t>•  총 11,085건 무중단 자동 수집 (측정소 5곳, 1시간 해상도)</a:t>
+              <a:t>•  총 12,855건 무중단 자동 수집 (측정소 5곳, 1시간 해상도)</a:t>
             </a:r>
           </a:p>
           <a:p>
@@ -3993,7 +3993,7 @@
                   <a:srgbClr val="555555"/>
                 </a:solidFill>
               </a:rPr>
-              <a:t>•  최저 공정능력: 오송읍 초미세먼지 (PM2.5) Cpk=0.246 → 우선 관리 대상</a:t>
+              <a:t>•  최저 공정능력: 오송읍 초미세먼지 (PM2.5) Cpk=0.279 → 우선 관리 대상</a:t>
             </a:r>
           </a:p>
           <a:p>
@@ -4008,7 +4008,7 @@
                   <a:srgbClr val="555555"/>
                 </a:solidFill>
               </a:rPr>
-              <a:t>•  PM2.5 산단 vs 거주지: '산단 영향군'가 '베이스라인'보다 평균 3.52 높음 (p=0.0000, 효과크기 작음 d=0.26).</a:t>
+              <a:t>•  PM2.5 산단 vs 거주지: '산단 영향군'가 '베이스라인'보다 평균 2.85 높음 (p=0.0000, 효과크기 작음 d=0.22).</a:t>
             </a:r>
           </a:p>
           <a:p>
@@ -4023,7 +4023,7 @@
                   <a:srgbClr val="555555"/>
                 </a:solidFill>
               </a:rPr>
-              <a:t>•  IsolationForest 다변량 이상탐지: 5개 측정소에서 총 1434건의 복합 이상 패턴 자동 탐지</a:t>
+              <a:t>•  IsolationForest 다변량 이상탐지: 5개 측정소에서 총 1624건의 복합 이상 패턴 자동 탐지</a:t>
             </a:r>
           </a:p>
           <a:p>

</xml_diff>